<commit_message>
refactor: change Medical Acts form color scheme from green to pink (#fca5a5)
</commit_message>
<xml_diff>
--- a/Presentations/RhumatoAI-Poster.pptx
+++ b/Presentations/RhumatoAI-Poster.pptx
@@ -4046,36 +4046,6 @@
       </p:pic>
       <p:pic>
         <p:nvPicPr>
-          <p:cNvPr id="61" name="Image 60">
-            <a:extLst>
-              <a:ext uri="{FF2B5EF4-FFF2-40B4-BE49-F238E27FC236}">
-                <a16:creationId xmlns:a16="http://schemas.microsoft.com/office/drawing/2014/main" id="{65AB5FA9-3A87-090A-B78E-B936CC3C91FD}"/>
-              </a:ext>
-            </a:extLst>
-          </p:cNvPr>
-          <p:cNvPicPr>
-            <a:picLocks noChangeAspect="1"/>
-          </p:cNvPicPr>
-          <p:nvPr/>
-        </p:nvPicPr>
-        <p:blipFill>
-          <a:blip r:embed="rId8"/>
-          <a:stretch>
-            <a:fillRect/>
-          </a:stretch>
-        </p:blipFill>
-        <p:spPr>
-          <a:xfrm>
-            <a:off x="1733550" y="-73152"/>
-            <a:ext cx="1119378" cy="870174"/>
-          </a:xfrm>
-          <a:prstGeom prst="rect">
-            <a:avLst/>
-          </a:prstGeom>
-        </p:spPr>
-      </p:pic>
-      <p:pic>
-        <p:nvPicPr>
           <p:cNvPr id="70" name="Image 69">
             <a:extLst>
               <a:ext uri="{FF2B5EF4-FFF2-40B4-BE49-F238E27FC236}">
@@ -4089,6 +4059,36 @@
           <p:nvPr/>
         </p:nvPicPr>
         <p:blipFill>
+          <a:blip r:embed="rId8"/>
+          <a:stretch>
+            <a:fillRect/>
+          </a:stretch>
+        </p:blipFill>
+        <p:spPr>
+          <a:xfrm>
+            <a:off x="7531004" y="9549"/>
+            <a:ext cx="1494124" cy="735497"/>
+          </a:xfrm>
+          <a:prstGeom prst="rect">
+            <a:avLst/>
+          </a:prstGeom>
+        </p:spPr>
+      </p:pic>
+      <p:pic>
+        <p:nvPicPr>
+          <p:cNvPr id="55" name="Image 54">
+            <a:extLst>
+              <a:ext uri="{FF2B5EF4-FFF2-40B4-BE49-F238E27FC236}">
+                <a16:creationId xmlns:a16="http://schemas.microsoft.com/office/drawing/2014/main" id="{8D0B0727-17A0-6B8D-88FA-AAD8C200831B}"/>
+              </a:ext>
+            </a:extLst>
+          </p:cNvPr>
+          <p:cNvPicPr>
+            <a:picLocks noChangeAspect="1"/>
+          </p:cNvPicPr>
+          <p:nvPr/>
+        </p:nvPicPr>
+        <p:blipFill>
           <a:blip r:embed="rId9"/>
           <a:stretch>
             <a:fillRect/>
@@ -4096,8 +4096,8 @@
         </p:blipFill>
         <p:spPr>
           <a:xfrm>
-            <a:off x="7531004" y="9549"/>
-            <a:ext cx="1494124" cy="735497"/>
+            <a:off x="1483441" y="162647"/>
+            <a:ext cx="1560256" cy="422569"/>
           </a:xfrm>
           <a:prstGeom prst="rect">
             <a:avLst/>

</xml_diff>

<commit_message>
profile pic upload, actibity track, and avatar display
</commit_message>
<xml_diff>
--- a/Presentations/RhumatoAI-Poster.pptx
+++ b/Presentations/RhumatoAI-Poster.pptx
@@ -812,7 +812,7 @@
         </p:nvSpPr>
         <p:spPr>
           <a:xfrm>
-            <a:off x="374904" y="603504"/>
+            <a:off x="305477" y="445007"/>
             <a:ext cx="8412480" cy="822960"/>
           </a:xfrm>
           <a:prstGeom prst="rect">
@@ -849,7 +849,7 @@
         </p:nvSpPr>
         <p:spPr>
           <a:xfrm>
-            <a:off x="466344" y="1181100"/>
+            <a:off x="456542" y="1047496"/>
             <a:ext cx="8412480" cy="237744"/>
           </a:xfrm>
           <a:prstGeom prst="rect">
@@ -872,7 +872,7 @@
                 <a:ea typeface="Calibri" pitchFamily="34" charset="-122"/>
                 <a:cs typeface="Calibri" pitchFamily="34" charset="-120"/>
               </a:rPr>
-              <a:t>Dr. Samy Housbane</a:t>
+              <a:t>M. Ismail Bakraoui </a:t>
             </a:r>
             <a:r>
               <a:rPr lang="en-US" sz="1400" dirty="0">
@@ -895,18 +895,10 @@
                 <a:ea typeface="Calibri" pitchFamily="34" charset="-122"/>
                 <a:cs typeface="Calibri" pitchFamily="34" charset="-120"/>
               </a:rPr>
-              <a:t> · Dr. Khaoula Ajbal</a:t>
+              <a:t> · Mme. Khaoula </a:t>
             </a:r>
             <a:r>
-              <a:rPr lang="en-US" sz="1400" dirty="0">
-                <a:solidFill>
-                  <a:schemeClr val="bg1"/>
-                </a:solidFill>
-              </a:rPr>
-              <a:t>²</a:t>
-            </a:r>
-            <a:r>
-              <a:rPr lang="en-US" sz="1200" i="1" dirty="0">
+              <a:rPr lang="en-US" sz="1200" i="1" dirty="0" err="1">
                 <a:solidFill>
                   <a:srgbClr val="A5F3FC"/>
                 </a:solidFill>
@@ -914,7 +906,59 @@
                 <a:ea typeface="Calibri" pitchFamily="34" charset="-122"/>
                 <a:cs typeface="Calibri" pitchFamily="34" charset="-120"/>
               </a:rPr>
-              <a:t> · M. Ismail Bakraoui</a:t>
+              <a:t>Ajbal</a:t>
+            </a:r>
+            <a:r>
+              <a:rPr lang="en-US" sz="1200" i="1" dirty="0">
+                <a:solidFill>
+                  <a:srgbClr val="A5F3FC"/>
+                </a:solidFill>
+                <a:latin typeface="Calibri" pitchFamily="34" charset="0"/>
+                <a:ea typeface="Calibri" pitchFamily="34" charset="-122"/>
+                <a:cs typeface="Calibri" pitchFamily="34" charset="-120"/>
+              </a:rPr>
+              <a:t> </a:t>
+            </a:r>
+            <a:r>
+              <a:rPr lang="en-US" sz="1400" dirty="0">
+                <a:solidFill>
+                  <a:schemeClr val="bg1"/>
+                </a:solidFill>
+              </a:rPr>
+              <a:t>¹</a:t>
+            </a:r>
+            <a:r>
+              <a:rPr lang="en-US" sz="1200" i="1" dirty="0">
+                <a:solidFill>
+                  <a:srgbClr val="A5F3FC"/>
+                </a:solidFill>
+                <a:latin typeface="Calibri" pitchFamily="34" charset="0"/>
+                <a:ea typeface="Calibri" pitchFamily="34" charset="-122"/>
+                <a:cs typeface="Calibri" pitchFamily="34" charset="-120"/>
+              </a:rPr>
+              <a:t> · M. Samy </a:t>
+            </a:r>
+            <a:r>
+              <a:rPr lang="en-US" sz="1200" i="1" dirty="0" err="1">
+                <a:solidFill>
+                  <a:srgbClr val="A5F3FC"/>
+                </a:solidFill>
+                <a:latin typeface="Calibri" pitchFamily="34" charset="0"/>
+                <a:ea typeface="Calibri" pitchFamily="34" charset="-122"/>
+                <a:cs typeface="Calibri" pitchFamily="34" charset="-120"/>
+              </a:rPr>
+              <a:t>Housbane</a:t>
+            </a:r>
+            <a:r>
+              <a:rPr lang="en-US" sz="1200" i="1" dirty="0">
+                <a:solidFill>
+                  <a:srgbClr val="A5F3FC"/>
+                </a:solidFill>
+                <a:latin typeface="Calibri" pitchFamily="34" charset="0"/>
+                <a:ea typeface="Calibri" pitchFamily="34" charset="-122"/>
+                <a:cs typeface="Calibri" pitchFamily="34" charset="-120"/>
+              </a:rPr>
+              <a:t> </a:t>
             </a:r>
             <a:r>
               <a:rPr lang="en-US" sz="1200" dirty="0">
@@ -922,7 +966,7 @@
                   <a:schemeClr val="bg1"/>
                 </a:solidFill>
               </a:rPr>
-              <a:t>²</a:t>
+              <a:t>²~³</a:t>
             </a:r>
           </a:p>
         </p:txBody>
@@ -935,7 +979,7 @@
         </p:nvSpPr>
         <p:spPr>
           <a:xfrm>
-            <a:off x="365760" y="1528572"/>
+            <a:off x="365760" y="1560768"/>
             <a:ext cx="8412480" cy="201168"/>
           </a:xfrm>
           <a:prstGeom prst="rect">
@@ -948,9 +992,7 @@
           <a:bodyPr wrap="square" lIns="0" tIns="0" rIns="0" bIns="0" rtlCol="0" anchor="ctr"/>
           <a:lstStyle/>
           <a:p>
-            <a:pPr marL="0" indent="0" algn="ctr">
-              <a:buNone/>
-            </a:pPr>
+            <a:pPr algn="ctr"/>
             <a:r>
               <a:rPr lang="en-US" sz="1000" dirty="0">
                 <a:solidFill>
@@ -960,7 +1002,7 @@
                 <a:ea typeface="Calibri" pitchFamily="34" charset="-122"/>
                 <a:cs typeface="Calibri" pitchFamily="34" charset="-120"/>
               </a:rPr>
-              <a:t>1 – Laboratory of Therapeutic innovation and artificial intelligence in health, FMPC – Hassan II, University of Casablanca</a:t>
+              <a:t>1 –  Laboratory of intelligent systems and applications, EMSI Tangier</a:t>
             </a:r>
           </a:p>
           <a:p>
@@ -974,8 +1016,25 @@
                 <a:ea typeface="Calibri" pitchFamily="34" charset="-122"/>
                 <a:cs typeface="Calibri" pitchFamily="34" charset="-120"/>
               </a:rPr>
-              <a:t>2 –  Laboratory of intelligent systems and applications, EMSI Tangier</a:t>
+              <a:t> 2 – Laboratory of Therapeutic innovation and artificial intelligence in health, FMPC – Hassan II, University of Casablanca</a:t>
             </a:r>
+          </a:p>
+          <a:p>
+            <a:pPr algn="ctr"/>
+            <a:r>
+              <a:rPr lang="en-US" sz="1000" dirty="0">
+                <a:solidFill>
+                  <a:srgbClr val="7DD3FC"/>
+                </a:solidFill>
+                <a:latin typeface="Calibri" pitchFamily="34" charset="0"/>
+                <a:ea typeface="Calibri" pitchFamily="34" charset="-122"/>
+                <a:cs typeface="Calibri" pitchFamily="34" charset="-120"/>
+              </a:rPr>
+              <a:t>3 – IBN ROCHD University Hospital Center, Casablanca</a:t>
+            </a:r>
+          </a:p>
+          <a:p>
+            <a:pPr algn="ctr"/>
             <a:endParaRPr lang="en-US" sz="1000" dirty="0"/>
           </a:p>
         </p:txBody>
@@ -1175,7 +1234,95 @@
                   <a:ea typeface="Calibri" pitchFamily="34" charset="-122"/>
                   <a:cs typeface="Calibri" pitchFamily="34" charset="-120"/>
                 </a:rPr>
-                <a:t>Deployed at CHU Ibn Rochd (Casablanca), the system enables secure, real-time interaction with patient data and AI-assisted clinical support within a fully on-premise infrastructure. Leveraging a FastAPI backend, cross-platform interfaces, and BioMistral inference via Ollama, the platform achieves response latencies of 2–5 seconds under operational conditions.</a:t>
+                <a:t>Deployed at CHU Ibn </a:t>
+              </a:r>
+              <a:r>
+                <a:rPr lang="en-US" sz="780" dirty="0" err="1">
+                  <a:solidFill>
+                    <a:srgbClr val="475569"/>
+                  </a:solidFill>
+                  <a:latin typeface="Calibri" pitchFamily="34" charset="0"/>
+                  <a:ea typeface="Calibri" pitchFamily="34" charset="-122"/>
+                  <a:cs typeface="Calibri" pitchFamily="34" charset="-120"/>
+                </a:rPr>
+                <a:t>Rochd</a:t>
+              </a:r>
+              <a:r>
+                <a:rPr lang="en-US" sz="780" dirty="0">
+                  <a:solidFill>
+                    <a:srgbClr val="475569"/>
+                  </a:solidFill>
+                  <a:latin typeface="Calibri" pitchFamily="34" charset="0"/>
+                  <a:ea typeface="Calibri" pitchFamily="34" charset="-122"/>
+                  <a:cs typeface="Calibri" pitchFamily="34" charset="-120"/>
+                </a:rPr>
+                <a:t> (Casablanca), the system enables secure, real-time interaction with patient data and AI-assisted clinical support within a fully on-premise infrastructure. Leveraging a </a:t>
+              </a:r>
+              <a:r>
+                <a:rPr lang="en-US" sz="780" dirty="0" err="1">
+                  <a:solidFill>
+                    <a:srgbClr val="475569"/>
+                  </a:solidFill>
+                  <a:latin typeface="Calibri" pitchFamily="34" charset="0"/>
+                  <a:ea typeface="Calibri" pitchFamily="34" charset="-122"/>
+                  <a:cs typeface="Calibri" pitchFamily="34" charset="-120"/>
+                </a:rPr>
+                <a:t>FastAPI</a:t>
+              </a:r>
+              <a:r>
+                <a:rPr lang="en-US" sz="780" dirty="0">
+                  <a:solidFill>
+                    <a:srgbClr val="475569"/>
+                  </a:solidFill>
+                  <a:latin typeface="Calibri" pitchFamily="34" charset="0"/>
+                  <a:ea typeface="Calibri" pitchFamily="34" charset="-122"/>
+                  <a:cs typeface="Calibri" pitchFamily="34" charset="-120"/>
+                </a:rPr>
+                <a:t> backend, cross-platform interfaces, and </a:t>
+              </a:r>
+              <a:r>
+                <a:rPr lang="en-US" sz="780" dirty="0" err="1">
+                  <a:solidFill>
+                    <a:srgbClr val="475569"/>
+                  </a:solidFill>
+                  <a:latin typeface="Calibri" pitchFamily="34" charset="0"/>
+                  <a:ea typeface="Calibri" pitchFamily="34" charset="-122"/>
+                  <a:cs typeface="Calibri" pitchFamily="34" charset="-120"/>
+                </a:rPr>
+                <a:t>BioMistral</a:t>
+              </a:r>
+              <a:r>
+                <a:rPr lang="en-US" sz="780" dirty="0">
+                  <a:solidFill>
+                    <a:srgbClr val="475569"/>
+                  </a:solidFill>
+                  <a:latin typeface="Calibri" pitchFamily="34" charset="0"/>
+                  <a:ea typeface="Calibri" pitchFamily="34" charset="-122"/>
+                  <a:cs typeface="Calibri" pitchFamily="34" charset="-120"/>
+                </a:rPr>
+                <a:t> inference via </a:t>
+              </a:r>
+              <a:r>
+                <a:rPr lang="en-US" sz="780" dirty="0" err="1">
+                  <a:solidFill>
+                    <a:srgbClr val="475569"/>
+                  </a:solidFill>
+                  <a:latin typeface="Calibri" pitchFamily="34" charset="0"/>
+                  <a:ea typeface="Calibri" pitchFamily="34" charset="-122"/>
+                  <a:cs typeface="Calibri" pitchFamily="34" charset="-120"/>
+                </a:rPr>
+                <a:t>Ollama</a:t>
+              </a:r>
+              <a:r>
+                <a:rPr lang="en-US" sz="780" dirty="0">
+                  <a:solidFill>
+                    <a:srgbClr val="475569"/>
+                  </a:solidFill>
+                  <a:latin typeface="Calibri" pitchFamily="34" charset="0"/>
+                  <a:ea typeface="Calibri" pitchFamily="34" charset="-122"/>
+                  <a:cs typeface="Calibri" pitchFamily="34" charset="-120"/>
+                </a:rPr>
+                <a:t>, the platform achieves response latencies of 2–5 seconds under operational conditions.</a:t>
               </a:r>
               <a:endParaRPr lang="en-US" sz="780" dirty="0"/>
             </a:p>
@@ -1382,11 +1529,10 @@
               <a:bodyPr wrap="square" lIns="0" tIns="0" rIns="0" bIns="0" rtlCol="0" anchor="t"/>
               <a:lstStyle/>
               <a:p>
-                <a:pPr marL="0" indent="0" algn="l">
+                <a:pPr>
                   <a:spcAft>
                     <a:spcPts val="200"/>
                   </a:spcAft>
-                  <a:buNone/>
                 </a:pPr>
                 <a:r>
                   <a:rPr lang="en-US" sz="780" dirty="0">
@@ -1397,9 +1543,36 @@
                     <a:ea typeface="Calibri" pitchFamily="34" charset="-122"/>
                     <a:cs typeface="Calibri" pitchFamily="34" charset="-120"/>
                   </a:rPr>
-                  <a:t>Recent advances in machine learning have significantly expanded clinical decision support in rheumatology. Supervised models predict disease activity and guide therapeutic choices, while unsupervised approaches stratify patients into clinically meaningful phenotypes, enabling more personalized care.</a:t>
+                  <a:t>Recent advances in machine learning have significantly expanded clinical decision support in rheumatology. Supervised models predict disease activity and guide therapeutic choices, while unsupervised approaches stratify patients into clinically meaningful phenotypes, enabling more personalized care ¹.</a:t>
                 </a:r>
                 <a:endParaRPr lang="en-US" sz="780" dirty="0"/>
+              </a:p>
+              <a:p>
+                <a:pPr marL="0" indent="0" algn="l">
+                  <a:spcAft>
+                    <a:spcPts val="200"/>
+                  </a:spcAft>
+                  <a:buNone/>
+                </a:pPr>
+                <a:endParaRPr lang="en-US" sz="780" dirty="0"/>
+              </a:p>
+              <a:p>
+                <a:pPr>
+                  <a:spcAft>
+                    <a:spcPts val="200"/>
+                  </a:spcAft>
+                </a:pPr>
+                <a:r>
+                  <a:rPr lang="en-US" sz="780" dirty="0">
+                    <a:solidFill>
+                      <a:srgbClr val="475569"/>
+                    </a:solidFill>
+                    <a:latin typeface="Calibri" pitchFamily="34" charset="0"/>
+                    <a:ea typeface="Calibri" pitchFamily="34" charset="-122"/>
+                    <a:cs typeface="Calibri" pitchFamily="34" charset="-120"/>
+                  </a:rPr>
+                  <a:t>Generative AI — particularly large language models such as GPT-4 represents a further paradigm shift, demonstrating promising diagnostic support, enhanced patient education, and accelerated research workflows ⁴.</a:t>
+                </a:r>
               </a:p>
               <a:p>
                 <a:pPr marL="0" indent="0" algn="l">
@@ -1426,36 +1599,7 @@
                     <a:ea typeface="Calibri" pitchFamily="34" charset="-122"/>
                     <a:cs typeface="Calibri" pitchFamily="34" charset="-120"/>
                   </a:rPr>
-                  <a:t>Generative AI — particularly large language models such as GPT-4 — represents a further paradigm shift, demonstrating promising diagnostic support, enhanced patient education, and accelerated research workflows.</a:t>
-                </a:r>
-                <a:endParaRPr lang="en-US" sz="780" dirty="0"/>
-              </a:p>
-              <a:p>
-                <a:pPr marL="0" indent="0" algn="l">
-                  <a:spcAft>
-                    <a:spcPts val="200"/>
-                  </a:spcAft>
-                  <a:buNone/>
-                </a:pPr>
-                <a:endParaRPr lang="en-US" sz="780" dirty="0"/>
-              </a:p>
-              <a:p>
-                <a:pPr marL="0" indent="0" algn="l">
-                  <a:spcAft>
-                    <a:spcPts val="200"/>
-                  </a:spcAft>
-                  <a:buNone/>
-                </a:pPr>
-                <a:r>
-                  <a:rPr lang="en-US" sz="780" dirty="0">
-                    <a:solidFill>
-                      <a:srgbClr val="475569"/>
-                    </a:solidFill>
-                    <a:latin typeface="Calibri" pitchFamily="34" charset="0"/>
-                    <a:ea typeface="Calibri" pitchFamily="34" charset="-122"/>
-                    <a:cs typeface="Calibri" pitchFamily="34" charset="-120"/>
-                  </a:rPr>
-                  <a:t>However, translation into routine clinical practice remains limited due to algorithmic bias, insufficient external validation, lack of model transparency, and gaps in clinician training. These constraints underscore the need for rigorous evaluation frameworks and structured integration strategies.</a:t>
+                  <a:t>However, translation into routine clinical practice remains limited due to algorithmic bias, insufficient external validation, lack of model transparency, and gaps in clinician training ². These constraints underscore the need for rigorous evaluation frameworks and structured integration strategies.</a:t>
                 </a:r>
                 <a:endParaRPr lang="en-US" sz="780" dirty="0"/>
               </a:p>
@@ -1840,7 +1984,7 @@
                   <a:schemeClr val="bg1"/>
                 </a:solidFill>
               </a:rPr>
-              <a:t>Chen YM, Hsiao TH, Lin CH, Fann YC. Unlocking precision medicine: clinical applications of integrating health records, genetics, and immunology through artificial intelligence. J Biomed Sci. 2025 Feb 7.</a:t>
+              <a:t>1 - Chen YM, Hsiao TH, Lin CH, Fann YC. Unlocking precision medicine: clinical applications of integrating health records, genetics, and immunology through artificial intelligence. J Biomed Sci. 2025 Feb 7.</a:t>
             </a:r>
           </a:p>
           <a:p>
@@ -1849,6 +1993,14 @@
                 <a:spcPct val="150000"/>
               </a:lnSpc>
             </a:pPr>
+            <a:r>
+              <a:rPr lang="en-US" sz="800" dirty="0">
+                <a:solidFill>
+                  <a:schemeClr val="bg1"/>
+                </a:solidFill>
+              </a:rPr>
+              <a:t>2 - </a:t>
+            </a:r>
             <a:r>
               <a:rPr lang="en-US" sz="800" dirty="0" err="1">
                 <a:solidFill>
@@ -1872,6 +2024,14 @@
                 <a:spcPct val="150000"/>
               </a:lnSpc>
             </a:pPr>
+            <a:r>
+              <a:rPr lang="en-US" sz="800" dirty="0">
+                <a:solidFill>
+                  <a:schemeClr val="bg1"/>
+                </a:solidFill>
+              </a:rPr>
+              <a:t>3 - </a:t>
+            </a:r>
             <a:r>
               <a:rPr lang="en-US" sz="800" dirty="0" err="1">
                 <a:solidFill>
@@ -1949,7 +2109,7 @@
                   <a:schemeClr val="bg1"/>
                 </a:solidFill>
               </a:rPr>
-              <a:t>Kunal </a:t>
+              <a:t>4 - Kunal </a:t>
             </a:r>
             <a:r>
               <a:rPr lang="en-US" sz="800" dirty="0" err="1">
@@ -1990,6 +2150,14 @@
                 <a:spcPct val="150000"/>
               </a:lnSpc>
             </a:pPr>
+            <a:r>
+              <a:rPr lang="en-US" sz="800" dirty="0">
+                <a:solidFill>
+                  <a:schemeClr val="bg1"/>
+                </a:solidFill>
+              </a:rPr>
+              <a:t>5 - </a:t>
+            </a:r>
             <a:r>
               <a:rPr lang="en-US" sz="800" dirty="0" err="1">
                 <a:solidFill>
@@ -2181,10 +2349,10 @@
           </p:nvGrpSpPr>
           <p:grpSpPr>
             <a:xfrm>
-              <a:off x="-5323851" y="8436139"/>
-              <a:ext cx="4110228" cy="2284412"/>
-              <a:chOff x="310896" y="8825548"/>
-              <a:chExt cx="4110228" cy="2284412"/>
+              <a:off x="-5290530" y="8436139"/>
+              <a:ext cx="4076907" cy="2284412"/>
+              <a:chOff x="344217" y="8825548"/>
+              <a:chExt cx="4076907" cy="2284412"/>
             </a:xfrm>
           </p:grpSpPr>
           <p:sp>
@@ -2266,7 +2434,7 @@
             </p:nvSpPr>
             <p:spPr>
               <a:xfrm>
-                <a:off x="438912" y="10451592"/>
+                <a:off x="344217" y="9369593"/>
                 <a:ext cx="3858768" cy="256032"/>
               </a:xfrm>
               <a:prstGeom prst="rect">
@@ -2279,26 +2447,12 @@
               <a:bodyPr wrap="square" lIns="0" tIns="0" rIns="0" bIns="0" rtlCol="0" anchor="ctr"/>
               <a:lstStyle/>
               <a:p>
-                <a:pPr marL="0" indent="0">
-                  <a:buNone/>
+                <a:pPr>
+                  <a:spcAft>
+                    <a:spcPts val="200"/>
+                  </a:spcAft>
                 </a:pPr>
-                <a:r>
-                  <a:rPr lang="en-US" sz="750" dirty="0">
-                    <a:solidFill>
-                      <a:srgbClr val="475569"/>
-                    </a:solidFill>
-                    <a:latin typeface="Calibri" pitchFamily="34" charset="0"/>
-                    <a:ea typeface="Calibri" pitchFamily="34" charset="-122"/>
-                    <a:cs typeface="Calibri" pitchFamily="34" charset="-120"/>
-                  </a:rPr>
-                  <a:t>Sub-5s response latency across all AI consultation features under load.</a:t>
-                </a:r>
-              </a:p>
-              <a:p>
-                <a:pPr marL="0" indent="0">
-                  <a:buNone/>
-                </a:pPr>
-                <a:endParaRPr lang="en-US" sz="750" dirty="0">
+                <a:endParaRPr lang="en-US" sz="780" dirty="0">
                   <a:solidFill>
                     <a:srgbClr val="475569"/>
                   </a:solidFill>
@@ -2308,8 +2462,13 @@
                 </a:endParaRPr>
               </a:p>
               <a:p>
+                <a:pPr>
+                  <a:spcAft>
+                    <a:spcPts val="200"/>
+                  </a:spcAft>
+                </a:pPr>
                 <a:r>
-                  <a:rPr lang="en-US" sz="750" dirty="0">
+                  <a:rPr lang="en-US" sz="780" dirty="0">
                     <a:solidFill>
                       <a:srgbClr val="475569"/>
                     </a:solidFill>
@@ -2317,22 +2476,10 @@
                     <a:ea typeface="Calibri" pitchFamily="34" charset="-122"/>
                     <a:cs typeface="Calibri" pitchFamily="34" charset="-120"/>
                   </a:rPr>
-                  <a:t>20 concurrent clinical users supported per department without degradation.</a:t>
+                  <a:t>The system maintains sub-5 s latency for AI-assisted consultations, with API response times of 50–200 </a:t>
                 </a:r>
-              </a:p>
-              <a:p>
-                <a:endParaRPr lang="en-US" sz="750" dirty="0">
-                  <a:solidFill>
-                    <a:srgbClr val="475569"/>
-                  </a:solidFill>
-                  <a:latin typeface="Calibri" pitchFamily="34" charset="0"/>
-                  <a:ea typeface="Calibri" pitchFamily="34" charset="-122"/>
-                  <a:cs typeface="Calibri" pitchFamily="34" charset="-120"/>
-                </a:endParaRPr>
-              </a:p>
-              <a:p>
                 <a:r>
-                  <a:rPr lang="en-US" sz="750" dirty="0">
+                  <a:rPr lang="en-US" sz="780" dirty="0" err="1">
                     <a:solidFill>
                       <a:srgbClr val="475569"/>
                     </a:solidFill>
@@ -2340,22 +2487,10 @@
                     <a:ea typeface="Calibri" pitchFamily="34" charset="-122"/>
                     <a:cs typeface="Calibri" pitchFamily="34" charset="-120"/>
                   </a:rPr>
-                  <a:t>Non-chat API endpoints: 50–200 ms, PDF generation 500 ms – 3 s.</a:t>
+                  <a:t>ms</a:t>
                 </a:r>
-              </a:p>
-              <a:p>
-                <a:endParaRPr lang="en-US" sz="750" dirty="0">
-                  <a:solidFill>
-                    <a:srgbClr val="475569"/>
-                  </a:solidFill>
-                  <a:latin typeface="Calibri" pitchFamily="34" charset="0"/>
-                  <a:ea typeface="Calibri" pitchFamily="34" charset="-122"/>
-                  <a:cs typeface="Calibri" pitchFamily="34" charset="-120"/>
-                </a:endParaRPr>
-              </a:p>
-              <a:p>
                 <a:r>
-                  <a:rPr lang="en-US" sz="750" dirty="0">
+                  <a:rPr lang="en-US" sz="780" dirty="0">
                     <a:solidFill>
                       <a:srgbClr val="475569"/>
                     </a:solidFill>
@@ -2363,99 +2498,9 @@
                     <a:ea typeface="Calibri" pitchFamily="34" charset="-122"/>
                     <a:cs typeface="Calibri" pitchFamily="34" charset="-120"/>
                   </a:rPr>
-                  <a:t>JWT authentication and RBAC function reliably on web and mobile.</a:t>
+                  <a:t> and PDF generation within 0.5–3 s. It supports up to 20 concurrent clinical users per department without performance degradation. Security and compliance are ensured through JWT-based authentication, RBAC, and full audit logging aligned with CNDP requirements. Identified bottlenecks are mitigated via fallback strategies, with production deployment underway including replication and automated backups.</a:t>
                 </a:r>
-              </a:p>
-              <a:p>
-                <a:endParaRPr lang="en-US" sz="750" dirty="0">
-                  <a:solidFill>
-                    <a:srgbClr val="475569"/>
-                  </a:solidFill>
-                  <a:latin typeface="Calibri" pitchFamily="34" charset="0"/>
-                  <a:ea typeface="Calibri" pitchFamily="34" charset="-122"/>
-                  <a:cs typeface="Calibri" pitchFamily="34" charset="-120"/>
-                </a:endParaRPr>
-              </a:p>
-              <a:p>
-                <a:r>
-                  <a:rPr lang="en-US" sz="750" dirty="0">
-                    <a:solidFill>
-                      <a:srgbClr val="475569"/>
-                    </a:solidFill>
-                    <a:latin typeface="Calibri" pitchFamily="34" charset="0"/>
-                    <a:ea typeface="Calibri" pitchFamily="34" charset="-122"/>
-                    <a:cs typeface="Calibri" pitchFamily="34" charset="-120"/>
-                  </a:rPr>
-                  <a:t>Full audit logging with user and timestamp traceability for CNDP compliance.</a:t>
-                </a:r>
-              </a:p>
-              <a:p>
-                <a:endParaRPr lang="en-US" sz="750" dirty="0">
-                  <a:solidFill>
-                    <a:srgbClr val="475569"/>
-                  </a:solidFill>
-                  <a:latin typeface="Calibri" pitchFamily="34" charset="0"/>
-                  <a:ea typeface="Calibri" pitchFamily="34" charset="-122"/>
-                  <a:cs typeface="Calibri" pitchFamily="34" charset="-120"/>
-                </a:endParaRPr>
-              </a:p>
-              <a:p>
-                <a:r>
-                  <a:rPr lang="en-US" sz="750" dirty="0">
-                    <a:solidFill>
-                      <a:srgbClr val="475569"/>
-                    </a:solidFill>
-                    <a:latin typeface="Calibri" pitchFamily="34" charset="0"/>
-                    <a:ea typeface="Calibri" pitchFamily="34" charset="-122"/>
-                    <a:cs typeface="Calibri" pitchFamily="34" charset="-120"/>
-                  </a:rPr>
-                  <a:t>Known bottlenecks (serialized LLM inference, absence of semantic patient search) are identified — fallback and model-swap mitigation strategies are defined.</a:t>
-                </a:r>
-              </a:p>
-              <a:p>
-                <a:endParaRPr lang="en-US" sz="750" dirty="0">
-                  <a:solidFill>
-                    <a:srgbClr val="475569"/>
-                  </a:solidFill>
-                  <a:latin typeface="Calibri" pitchFamily="34" charset="0"/>
-                  <a:ea typeface="Calibri" pitchFamily="34" charset="-122"/>
-                  <a:cs typeface="Calibri" pitchFamily="34" charset="-120"/>
-                </a:endParaRPr>
-              </a:p>
-              <a:p>
-                <a:r>
-                  <a:rPr lang="en-US" sz="750" dirty="0">
-                    <a:solidFill>
-                      <a:srgbClr val="475569"/>
-                    </a:solidFill>
-                    <a:latin typeface="Calibri" pitchFamily="34" charset="0"/>
-                    <a:ea typeface="Calibri" pitchFamily="34" charset="-122"/>
-                    <a:cs typeface="Calibri" pitchFamily="34" charset="-120"/>
-                  </a:rPr>
-                  <a:t>Platform transitioning to production; database replication and automated backup scheduled before full deployment.</a:t>
-                </a:r>
-                <a:endParaRPr lang="en-US" sz="750" dirty="0"/>
-              </a:p>
-              <a:p>
-                <a:endParaRPr lang="en-US" sz="750" dirty="0"/>
-              </a:p>
-              <a:p>
-                <a:endParaRPr lang="en-US" sz="750" dirty="0"/>
-              </a:p>
-              <a:p>
-                <a:endParaRPr lang="en-US" sz="750" dirty="0"/>
-              </a:p>
-              <a:p>
-                <a:endParaRPr lang="en-US" sz="750" dirty="0"/>
-              </a:p>
-              <a:p>
-                <a:endParaRPr lang="en-US" sz="750" dirty="0"/>
-              </a:p>
-              <a:p>
-                <a:pPr marL="0" indent="0">
-                  <a:buNone/>
-                </a:pPr>
-                <a:endParaRPr lang="en-US" sz="750" dirty="0"/>
+                <a:endParaRPr lang="en-US" sz="780" dirty="0"/>
               </a:p>
             </p:txBody>
           </p:sp>
@@ -2512,272 +2557,6 @@
                   <a:buNone/>
                 </a:pPr>
                 <a:endParaRPr lang="en-US" sz="750" dirty="0"/>
-              </a:p>
-            </p:txBody>
-          </p:sp>
-          <p:sp>
-            <p:nvSpPr>
-              <p:cNvPr id="79" name="Shape 19">
-                <a:extLst>
-                  <a:ext uri="{FF2B5EF4-FFF2-40B4-BE49-F238E27FC236}">
-                    <a16:creationId xmlns:a16="http://schemas.microsoft.com/office/drawing/2014/main" id="{25C4FB41-1CA0-E353-DE12-F3D185E59677}"/>
-                  </a:ext>
-                </a:extLst>
-              </p:cNvPr>
-              <p:cNvSpPr/>
-              <p:nvPr/>
-            </p:nvSpPr>
-            <p:spPr>
-              <a:xfrm>
-                <a:off x="320040" y="9400032"/>
-                <a:ext cx="73152" cy="73152"/>
-              </a:xfrm>
-              <a:prstGeom prst="ellipse">
-                <a:avLst/>
-              </a:prstGeom>
-              <a:solidFill>
-                <a:srgbClr val="0D9488"/>
-              </a:solidFill>
-              <a:ln w="12700">
-                <a:solidFill>
-                  <a:srgbClr val="0D9488"/>
-                </a:solidFill>
-                <a:prstDash val="solid"/>
-              </a:ln>
-            </p:spPr>
-            <p:txBody>
-              <a:bodyPr/>
-              <a:lstStyle/>
-              <a:p>
-                <a:endParaRPr lang="en-US"/>
-              </a:p>
-            </p:txBody>
-          </p:sp>
-          <p:sp>
-            <p:nvSpPr>
-              <p:cNvPr id="80" name="Shape 19">
-                <a:extLst>
-                  <a:ext uri="{FF2B5EF4-FFF2-40B4-BE49-F238E27FC236}">
-                    <a16:creationId xmlns:a16="http://schemas.microsoft.com/office/drawing/2014/main" id="{EC565790-5518-38D9-1B25-FB073E7294AC}"/>
-                  </a:ext>
-                </a:extLst>
-              </p:cNvPr>
-              <p:cNvSpPr/>
-              <p:nvPr/>
-            </p:nvSpPr>
-            <p:spPr>
-              <a:xfrm>
-                <a:off x="320040" y="9637776"/>
-                <a:ext cx="73152" cy="73152"/>
-              </a:xfrm>
-              <a:prstGeom prst="ellipse">
-                <a:avLst/>
-              </a:prstGeom>
-              <a:solidFill>
-                <a:srgbClr val="0D9488"/>
-              </a:solidFill>
-              <a:ln w="12700">
-                <a:solidFill>
-                  <a:srgbClr val="0D9488"/>
-                </a:solidFill>
-                <a:prstDash val="solid"/>
-              </a:ln>
-            </p:spPr>
-            <p:txBody>
-              <a:bodyPr/>
-              <a:lstStyle/>
-              <a:p>
-                <a:endParaRPr lang="en-US"/>
-              </a:p>
-            </p:txBody>
-          </p:sp>
-          <p:sp>
-            <p:nvSpPr>
-              <p:cNvPr id="81" name="Shape 19">
-                <a:extLst>
-                  <a:ext uri="{FF2B5EF4-FFF2-40B4-BE49-F238E27FC236}">
-                    <a16:creationId xmlns:a16="http://schemas.microsoft.com/office/drawing/2014/main" id="{E50D60C3-CEA3-AEB0-7943-AA016DF87E67}"/>
-                  </a:ext>
-                </a:extLst>
-              </p:cNvPr>
-              <p:cNvSpPr/>
-              <p:nvPr/>
-            </p:nvSpPr>
-            <p:spPr>
-              <a:xfrm>
-                <a:off x="321564" y="9857232"/>
-                <a:ext cx="73152" cy="73152"/>
-              </a:xfrm>
-              <a:prstGeom prst="ellipse">
-                <a:avLst/>
-              </a:prstGeom>
-              <a:solidFill>
-                <a:srgbClr val="0D9488"/>
-              </a:solidFill>
-              <a:ln w="12700">
-                <a:solidFill>
-                  <a:srgbClr val="0D9488"/>
-                </a:solidFill>
-                <a:prstDash val="solid"/>
-              </a:ln>
-            </p:spPr>
-            <p:txBody>
-              <a:bodyPr/>
-              <a:lstStyle/>
-              <a:p>
-                <a:endParaRPr lang="en-US"/>
-              </a:p>
-            </p:txBody>
-          </p:sp>
-          <p:sp>
-            <p:nvSpPr>
-              <p:cNvPr id="82" name="Shape 19">
-                <a:extLst>
-                  <a:ext uri="{FF2B5EF4-FFF2-40B4-BE49-F238E27FC236}">
-                    <a16:creationId xmlns:a16="http://schemas.microsoft.com/office/drawing/2014/main" id="{A028A132-D108-6DCD-958D-E7EF79BA649A}"/>
-                  </a:ext>
-                </a:extLst>
-              </p:cNvPr>
-              <p:cNvSpPr/>
-              <p:nvPr/>
-            </p:nvSpPr>
-            <p:spPr>
-              <a:xfrm>
-                <a:off x="315468" y="10093452"/>
-                <a:ext cx="73152" cy="73152"/>
-              </a:xfrm>
-              <a:prstGeom prst="ellipse">
-                <a:avLst/>
-              </a:prstGeom>
-              <a:solidFill>
-                <a:srgbClr val="0D9488"/>
-              </a:solidFill>
-              <a:ln w="12700">
-                <a:solidFill>
-                  <a:srgbClr val="0D9488"/>
-                </a:solidFill>
-                <a:prstDash val="solid"/>
-              </a:ln>
-            </p:spPr>
-            <p:txBody>
-              <a:bodyPr/>
-              <a:lstStyle/>
-              <a:p>
-                <a:endParaRPr lang="en-US"/>
-              </a:p>
-            </p:txBody>
-          </p:sp>
-          <p:sp>
-            <p:nvSpPr>
-              <p:cNvPr id="83" name="Shape 19">
-                <a:extLst>
-                  <a:ext uri="{FF2B5EF4-FFF2-40B4-BE49-F238E27FC236}">
-                    <a16:creationId xmlns:a16="http://schemas.microsoft.com/office/drawing/2014/main" id="{05508166-E596-F35B-E8B1-517BE7C94856}"/>
-                  </a:ext>
-                </a:extLst>
-              </p:cNvPr>
-              <p:cNvSpPr/>
-              <p:nvPr/>
-            </p:nvSpPr>
-            <p:spPr>
-              <a:xfrm>
-                <a:off x="315468" y="10300588"/>
-                <a:ext cx="73152" cy="73152"/>
-              </a:xfrm>
-              <a:prstGeom prst="ellipse">
-                <a:avLst/>
-              </a:prstGeom>
-              <a:solidFill>
-                <a:srgbClr val="0D9488"/>
-              </a:solidFill>
-              <a:ln w="12700">
-                <a:solidFill>
-                  <a:srgbClr val="0D9488"/>
-                </a:solidFill>
-                <a:prstDash val="solid"/>
-              </a:ln>
-            </p:spPr>
-            <p:txBody>
-              <a:bodyPr/>
-              <a:lstStyle/>
-              <a:p>
-                <a:endParaRPr lang="en-US"/>
-              </a:p>
-            </p:txBody>
-          </p:sp>
-          <p:sp>
-            <p:nvSpPr>
-              <p:cNvPr id="84" name="Shape 19">
-                <a:extLst>
-                  <a:ext uri="{FF2B5EF4-FFF2-40B4-BE49-F238E27FC236}">
-                    <a16:creationId xmlns:a16="http://schemas.microsoft.com/office/drawing/2014/main" id="{2D716D8C-5E73-2895-4797-212027DEA504}"/>
-                  </a:ext>
-                </a:extLst>
-              </p:cNvPr>
-              <p:cNvSpPr/>
-              <p:nvPr/>
-            </p:nvSpPr>
-            <p:spPr>
-              <a:xfrm>
-                <a:off x="310896" y="10544428"/>
-                <a:ext cx="73152" cy="73152"/>
-              </a:xfrm>
-              <a:prstGeom prst="ellipse">
-                <a:avLst/>
-              </a:prstGeom>
-              <a:solidFill>
-                <a:srgbClr val="0D9488"/>
-              </a:solidFill>
-              <a:ln w="12700">
-                <a:solidFill>
-                  <a:srgbClr val="0D9488"/>
-                </a:solidFill>
-                <a:prstDash val="solid"/>
-              </a:ln>
-            </p:spPr>
-            <p:txBody>
-              <a:bodyPr/>
-              <a:lstStyle/>
-              <a:p>
-                <a:endParaRPr lang="en-US"/>
-              </a:p>
-            </p:txBody>
-          </p:sp>
-          <p:sp>
-            <p:nvSpPr>
-              <p:cNvPr id="85" name="Shape 19">
-                <a:extLst>
-                  <a:ext uri="{FF2B5EF4-FFF2-40B4-BE49-F238E27FC236}">
-                    <a16:creationId xmlns:a16="http://schemas.microsoft.com/office/drawing/2014/main" id="{3F0CCA30-75BC-7848-3A26-917ED02AC5E7}"/>
-                  </a:ext>
-                </a:extLst>
-              </p:cNvPr>
-              <p:cNvSpPr/>
-              <p:nvPr/>
-            </p:nvSpPr>
-            <p:spPr>
-              <a:xfrm>
-                <a:off x="310896" y="10894820"/>
-                <a:ext cx="73152" cy="73152"/>
-              </a:xfrm>
-              <a:prstGeom prst="ellipse">
-                <a:avLst/>
-              </a:prstGeom>
-              <a:solidFill>
-                <a:srgbClr val="0D9488"/>
-              </a:solidFill>
-              <a:ln w="12700">
-                <a:solidFill>
-                  <a:srgbClr val="0D9488"/>
-                </a:solidFill>
-                <a:prstDash val="solid"/>
-              </a:ln>
-            </p:spPr>
-            <p:txBody>
-              <a:bodyPr/>
-              <a:lstStyle/>
-              <a:p>
-                <a:endParaRPr lang="en-US"/>
               </a:p>
             </p:txBody>
           </p:sp>
@@ -2856,10 +2635,10 @@
           </p:nvGrpSpPr>
           <p:grpSpPr>
             <a:xfrm>
-              <a:off x="10104435" y="7374636"/>
-              <a:ext cx="4050792" cy="3341722"/>
-              <a:chOff x="4764024" y="4919472"/>
-              <a:chExt cx="4050792" cy="3341722"/>
+              <a:off x="10108160" y="7374636"/>
+              <a:ext cx="4028779" cy="1900990"/>
+              <a:chOff x="4767749" y="4919472"/>
+              <a:chExt cx="4028779" cy="1900990"/>
             </a:xfrm>
           </p:grpSpPr>
           <p:sp>
@@ -2935,38 +2714,6 @@
           </p:sp>
           <p:sp>
             <p:nvSpPr>
-              <p:cNvPr id="37" name="Shape 35"/>
-              <p:cNvSpPr/>
-              <p:nvPr/>
-            </p:nvSpPr>
-            <p:spPr>
-              <a:xfrm>
-                <a:off x="4809744" y="5266944"/>
-                <a:ext cx="1243584" cy="658368"/>
-              </a:xfrm>
-              <a:prstGeom prst="rect">
-                <a:avLst/>
-              </a:prstGeom>
-              <a:solidFill>
-                <a:srgbClr val="F0F4F8"/>
-              </a:solidFill>
-              <a:ln w="6350">
-                <a:solidFill>
-                  <a:srgbClr val="E2E8F0"/>
-                </a:solidFill>
-                <a:prstDash val="solid"/>
-              </a:ln>
-            </p:spPr>
-            <p:txBody>
-              <a:bodyPr/>
-              <a:lstStyle/>
-              <a:p>
-                <a:endParaRPr lang="en-US"/>
-              </a:p>
-            </p:txBody>
-          </p:sp>
-          <p:sp>
-            <p:nvSpPr>
               <p:cNvPr id="38" name="Text 36"/>
               <p:cNvSpPr/>
               <p:nvPr/>
@@ -2989,106 +2736,7 @@
                 <a:pPr marL="0" indent="0" algn="ctr">
                   <a:buNone/>
                 </a:pPr>
-                <a:r>
-                  <a:rPr lang="en-US" sz="1600" b="1" dirty="0">
-                    <a:solidFill>
-                      <a:srgbClr val="0D9488"/>
-                    </a:solidFill>
-                    <a:latin typeface="Calibri" pitchFamily="34" charset="0"/>
-                    <a:ea typeface="Calibri" pitchFamily="34" charset="-122"/>
-                    <a:cs typeface="Calibri" pitchFamily="34" charset="-120"/>
-                  </a:rPr>
-                  <a:t>2–5 s</a:t>
-                </a:r>
                 <a:endParaRPr lang="en-US" sz="1600" dirty="0"/>
-              </a:p>
-            </p:txBody>
-          </p:sp>
-          <p:sp>
-            <p:nvSpPr>
-              <p:cNvPr id="39" name="Text 37"/>
-              <p:cNvSpPr/>
-              <p:nvPr/>
-            </p:nvSpPr>
-            <p:spPr>
-              <a:xfrm>
-                <a:off x="4809744" y="5577840"/>
-                <a:ext cx="1243584" cy="310896"/>
-              </a:xfrm>
-              <a:prstGeom prst="rect">
-                <a:avLst/>
-              </a:prstGeom>
-              <a:noFill/>
-              <a:ln/>
-            </p:spPr>
-            <p:txBody>
-              <a:bodyPr wrap="square" lIns="0" tIns="0" rIns="0" bIns="0" rtlCol="0" anchor="ctr"/>
-              <a:lstStyle/>
-              <a:p>
-                <a:pPr marL="0" indent="0" algn="ctr">
-                  <a:buNone/>
-                </a:pPr>
-                <a:r>
-                  <a:rPr lang="en-US" sz="800" dirty="0">
-                    <a:solidFill>
-                      <a:srgbClr val="94A3B8"/>
-                    </a:solidFill>
-                    <a:latin typeface="Calibri" pitchFamily="34" charset="0"/>
-                    <a:ea typeface="Calibri" pitchFamily="34" charset="-122"/>
-                    <a:cs typeface="Calibri" pitchFamily="34" charset="-120"/>
-                  </a:rPr>
-                  <a:t>AI consultation</a:t>
-                </a:r>
-                <a:endParaRPr lang="en-US" sz="800" dirty="0"/>
-              </a:p>
-              <a:p>
-                <a:pPr marL="0" indent="0" algn="ctr">
-                  <a:buNone/>
-                </a:pPr>
-                <a:r>
-                  <a:rPr lang="en-US" sz="800" dirty="0">
-                    <a:solidFill>
-                      <a:srgbClr val="94A3B8"/>
-                    </a:solidFill>
-                    <a:latin typeface="Calibri" pitchFamily="34" charset="0"/>
-                    <a:ea typeface="Calibri" pitchFamily="34" charset="-122"/>
-                    <a:cs typeface="Calibri" pitchFamily="34" charset="-120"/>
-                  </a:rPr>
-                  <a:t>response time</a:t>
-                </a:r>
-                <a:endParaRPr lang="en-US" sz="800" dirty="0"/>
-              </a:p>
-            </p:txBody>
-          </p:sp>
-          <p:sp>
-            <p:nvSpPr>
-              <p:cNvPr id="40" name="Shape 38"/>
-              <p:cNvSpPr/>
-              <p:nvPr/>
-            </p:nvSpPr>
-            <p:spPr>
-              <a:xfrm>
-                <a:off x="6126480" y="5266944"/>
-                <a:ext cx="1243584" cy="658368"/>
-              </a:xfrm>
-              <a:prstGeom prst="rect">
-                <a:avLst/>
-              </a:prstGeom>
-              <a:solidFill>
-                <a:srgbClr val="F0F4F8"/>
-              </a:solidFill>
-              <a:ln w="6350">
-                <a:solidFill>
-                  <a:srgbClr val="E2E8F0"/>
-                </a:solidFill>
-                <a:prstDash val="solid"/>
-              </a:ln>
-            </p:spPr>
-            <p:txBody>
-              <a:bodyPr/>
-              <a:lstStyle/>
-              <a:p>
-                <a:endParaRPr lang="en-US"/>
               </a:p>
             </p:txBody>
           </p:sp>
@@ -3116,17 +2764,6 @@
                 <a:pPr marL="0" indent="0" algn="ctr">
                   <a:buNone/>
                 </a:pPr>
-                <a:r>
-                  <a:rPr lang="en-US" sz="1600" b="1" dirty="0">
-                    <a:solidFill>
-                      <a:srgbClr val="0D9488"/>
-                    </a:solidFill>
-                    <a:latin typeface="Calibri" pitchFamily="34" charset="0"/>
-                    <a:ea typeface="Calibri" pitchFamily="34" charset="-122"/>
-                    <a:cs typeface="Calibri" pitchFamily="34" charset="-120"/>
-                  </a:rPr>
-                  <a:t>50–200 ms</a:t>
-                </a:r>
                 <a:endParaRPr lang="en-US" sz="1600" dirty="0"/>
               </a:p>
             </p:txBody>
@@ -3155,66 +2792,7 @@
                 <a:pPr marL="0" indent="0" algn="ctr">
                   <a:buNone/>
                 </a:pPr>
-                <a:r>
-                  <a:rPr lang="en-US" sz="800" dirty="0">
-                    <a:solidFill>
-                      <a:srgbClr val="94A3B8"/>
-                    </a:solidFill>
-                    <a:latin typeface="Calibri" pitchFamily="34" charset="0"/>
-                    <a:ea typeface="Calibri" pitchFamily="34" charset="-122"/>
-                    <a:cs typeface="Calibri" pitchFamily="34" charset="-120"/>
-                  </a:rPr>
-                  <a:t>Standard data</a:t>
-                </a:r>
-              </a:p>
-              <a:p>
-                <a:pPr marL="0" indent="0" algn="ctr">
-                  <a:buNone/>
-                </a:pPr>
-                <a:r>
-                  <a:rPr lang="en-US" sz="800" dirty="0">
-                    <a:solidFill>
-                      <a:srgbClr val="94A3B8"/>
-                    </a:solidFill>
-                    <a:latin typeface="Calibri" pitchFamily="34" charset="0"/>
-                    <a:ea typeface="Calibri" pitchFamily="34" charset="-122"/>
-                    <a:cs typeface="Calibri" pitchFamily="34" charset="-120"/>
-                  </a:rPr>
-                  <a:t>retrieval latency</a:t>
-                </a:r>
                 <a:endParaRPr lang="en-US" sz="800" dirty="0"/>
-              </a:p>
-            </p:txBody>
-          </p:sp>
-          <p:sp>
-            <p:nvSpPr>
-              <p:cNvPr id="43" name="Shape 41"/>
-              <p:cNvSpPr/>
-              <p:nvPr/>
-            </p:nvSpPr>
-            <p:spPr>
-              <a:xfrm>
-                <a:off x="7443216" y="5266944"/>
-                <a:ext cx="1243584" cy="658368"/>
-              </a:xfrm>
-              <a:prstGeom prst="rect">
-                <a:avLst/>
-              </a:prstGeom>
-              <a:solidFill>
-                <a:srgbClr val="F0F4F8"/>
-              </a:solidFill>
-              <a:ln w="6350">
-                <a:solidFill>
-                  <a:srgbClr val="E2E8F0"/>
-                </a:solidFill>
-                <a:prstDash val="solid"/>
-              </a:ln>
-            </p:spPr>
-            <p:txBody>
-              <a:bodyPr/>
-              <a:lstStyle/>
-              <a:p>
-                <a:endParaRPr lang="en-US"/>
               </a:p>
             </p:txBody>
           </p:sp>
@@ -3242,74 +2820,7 @@
                 <a:pPr marL="0" indent="0" algn="ctr">
                   <a:buNone/>
                 </a:pPr>
-                <a:r>
-                  <a:rPr lang="en-US" sz="1600" b="1" dirty="0">
-                    <a:solidFill>
-                      <a:srgbClr val="0D9488"/>
-                    </a:solidFill>
-                    <a:latin typeface="Calibri" pitchFamily="34" charset="0"/>
-                    <a:ea typeface="Calibri" pitchFamily="34" charset="-122"/>
-                    <a:cs typeface="Calibri" pitchFamily="34" charset="-120"/>
-                  </a:rPr>
-                  <a:t>18,000+</a:t>
-                </a:r>
                 <a:endParaRPr lang="en-US" sz="1600" dirty="0"/>
-              </a:p>
-            </p:txBody>
-          </p:sp>
-          <p:sp>
-            <p:nvSpPr>
-              <p:cNvPr id="45" name="Text 43"/>
-              <p:cNvSpPr/>
-              <p:nvPr/>
-            </p:nvSpPr>
-            <p:spPr>
-              <a:xfrm>
-                <a:off x="7443216" y="5577840"/>
-                <a:ext cx="1243584" cy="310896"/>
-              </a:xfrm>
-              <a:prstGeom prst="rect">
-                <a:avLst/>
-              </a:prstGeom>
-              <a:noFill/>
-              <a:ln/>
-            </p:spPr>
-            <p:txBody>
-              <a:bodyPr wrap="square" lIns="0" tIns="0" rIns="0" bIns="0" rtlCol="0" anchor="ctr"/>
-              <a:lstStyle/>
-              <a:p>
-                <a:pPr marL="0" indent="0" algn="ctr">
-                  <a:buNone/>
-                </a:pPr>
-                <a:r>
-                  <a:rPr lang="en-US" sz="800" dirty="0">
-                    <a:solidFill>
-                      <a:srgbClr val="94A3B8"/>
-                    </a:solidFill>
-                    <a:latin typeface="Calibri" pitchFamily="34" charset="0"/>
-                    <a:ea typeface="Calibri" pitchFamily="34" charset="-122"/>
-                    <a:cs typeface="Calibri" pitchFamily="34" charset="-120"/>
-                  </a:rPr>
-                  <a:t>Patient records</a:t>
-                </a:r>
-                <a:endParaRPr lang="en-US" sz="800" dirty="0"/>
-              </a:p>
-              <a:p>
-                <a:pPr marL="0" indent="0" algn="ctr">
-                  <a:buNone/>
-                </a:pPr>
-                <a:r>
-                  <a:rPr lang="en-US" sz="800" dirty="0">
-                    <a:solidFill>
-                      <a:srgbClr val="94A3B8"/>
-                    </a:solidFill>
-                    <a:latin typeface="Calibri" pitchFamily="34" charset="0"/>
-                    <a:ea typeface="Calibri" pitchFamily="34" charset="-122"/>
-                    <a:cs typeface="Calibri" pitchFamily="34" charset="-120"/>
-                  </a:rPr>
-                  <a:t>managed</a:t>
-                </a:r>
-                <a:endParaRPr lang="en-US" sz="800" dirty="0"/>
               </a:p>
             </p:txBody>
           </p:sp>
@@ -3321,7 +2832,7 @@
             </p:nvSpPr>
             <p:spPr>
               <a:xfrm>
-                <a:off x="4809744" y="6016752"/>
+                <a:off x="4767749" y="5265982"/>
                 <a:ext cx="3986784" cy="1554480"/>
               </a:xfrm>
               <a:prstGeom prst="rect">
@@ -3334,97 +2845,33 @@
               <a:bodyPr wrap="square" lIns="0" tIns="0" rIns="0" bIns="0" rtlCol="0" anchor="t"/>
               <a:lstStyle/>
               <a:p>
-                <a:pPr marL="0" indent="0" algn="l">
-                  <a:spcAft>
-                    <a:spcPts val="200"/>
-                  </a:spcAft>
-                  <a:buNone/>
-                </a:pPr>
                 <a:r>
-                  <a:rPr lang="en-US" sz="750" dirty="0">
-                    <a:solidFill>
-                      <a:srgbClr val="475569"/>
-                    </a:solidFill>
-                    <a:latin typeface="Calibri" pitchFamily="34" charset="0"/>
-                    <a:ea typeface="Calibri" pitchFamily="34" charset="-122"/>
-                    <a:cs typeface="Calibri" pitchFamily="34" charset="-120"/>
-                  </a:rPr>
-                  <a:t>The RhumatoAI platform instantiates a bidirectional care coordination model in which patient-generated health data and clinician-directed diagnostic information converge within a locally-managed computational environment. Patients contribute symptom narratives; clinicians provide diagnoses and lab interpretations; the system mediates with AI-augmented recommendations — all within institutional infrastructure.</a:t>
+                  <a:rPr lang="en-US" sz="800" dirty="0" err="1"/>
+                  <a:t>RhumatoAI</a:t>
                 </a:r>
-                <a:endParaRPr lang="en-US" sz="750" dirty="0"/>
-              </a:p>
-              <a:p>
-                <a:pPr marL="0" indent="0" algn="l">
-                  <a:spcAft>
-                    <a:spcPts val="200"/>
-                  </a:spcAft>
-                  <a:buNone/>
-                </a:pPr>
                 <a:r>
-                  <a:rPr lang="en-US" sz="750" dirty="0">
-                    <a:solidFill>
-                      <a:srgbClr val="475569"/>
-                    </a:solidFill>
-                    <a:latin typeface="Calibri" pitchFamily="34" charset="0"/>
-                    <a:ea typeface="Calibri" pitchFamily="34" charset="-122"/>
-                    <a:cs typeface="Calibri" pitchFamily="34" charset="-120"/>
-                  </a:rPr>
-                  <a:t>Core modules are fully operational: patient and clinical history management, appointment scheduling, medical documentation, and LLM-powered decision support. Role-based access control establishes hierarchical permission structures; comprehensive audit logging provides institutional accountability.</a:t>
+                  <a:rPr lang="en-US" sz="800" dirty="0"/>
+                  <a:t> implements bidirectional care coordination model integrating patient-generated symptom narratives with clinician-derived diagnoses and laboratory data computational environment. AI-mediated processing generates clinical recommendations institutional governance. Core modules include patient and clinical history management, appointment scheduling, medical documentation, LLM-assisted decision support. Role-based access control (RBAC) enforces hierarchical permissions supported audit logging institutional accountability. A single-instance </a:t>
                 </a:r>
-                <a:endParaRPr lang="en-US" sz="750" dirty="0"/>
-              </a:p>
-              <a:p>
-                <a:pPr marL="0" indent="0" algn="l">
-                  <a:spcAft>
-                    <a:spcPts val="200"/>
-                  </a:spcAft>
-                  <a:buNone/>
-                </a:pPr>
                 <a:r>
-                  <a:rPr lang="en-US" sz="750" dirty="0">
-                    <a:solidFill>
-                      <a:srgbClr val="475569"/>
-                    </a:solidFill>
-                    <a:latin typeface="Calibri" pitchFamily="34" charset="0"/>
-                    <a:ea typeface="Calibri" pitchFamily="34" charset="-122"/>
-                    <a:cs typeface="Calibri" pitchFamily="34" charset="-120"/>
-                  </a:rPr>
-                  <a:t>The single-instance BioMistral/Ollama deployment adequately sustains current workloads (10–20 concurrent practitioners per department). Horizontal scaling strategies — including multi-instance LLM orchestration and async task queues — are under evaluation for future deployment.</a:t>
+                  <a:rPr lang="en-US" sz="800" dirty="0" err="1"/>
+                  <a:t>BioMistral</a:t>
                 </a:r>
-                <a:endParaRPr lang="en-US" sz="750" dirty="0"/>
+                <a:r>
+                  <a:rPr lang="en-US" sz="800" dirty="0"/>
+                  <a:t>/</a:t>
+                </a:r>
+                <a:r>
+                  <a:rPr lang="en-US" sz="800" dirty="0" err="1"/>
+                  <a:t>Ollama</a:t>
+                </a:r>
+                <a:r>
+                  <a:rPr lang="en-US" sz="800" dirty="0"/>
+                  <a:t> deployment supports clinical load (10–20 concurrent practitioners per department). Future scaling being evaluated through multi-instance LLM orchestration and asynchronous task queues ⁵.</a:t>
+                </a:r>
               </a:p>
             </p:txBody>
           </p:sp>
-          <p:pic>
-            <p:nvPicPr>
-              <p:cNvPr id="89" name="Image 88">
-                <a:extLst>
-                  <a:ext uri="{FF2B5EF4-FFF2-40B4-BE49-F238E27FC236}">
-                    <a16:creationId xmlns:a16="http://schemas.microsoft.com/office/drawing/2014/main" id="{63DC4CDE-3EF7-F59C-65CB-4EF2AE38FBA7}"/>
-                  </a:ext>
-                </a:extLst>
-              </p:cNvPr>
-              <p:cNvPicPr>
-                <a:picLocks noChangeAspect="1"/>
-              </p:cNvPicPr>
-              <p:nvPr/>
-            </p:nvPicPr>
-            <p:blipFill>
-              <a:blip r:embed="rId3"/>
-              <a:stretch>
-                <a:fillRect/>
-              </a:stretch>
-            </p:blipFill>
-            <p:spPr>
-              <a:xfrm>
-                <a:off x="4764024" y="7429909"/>
-                <a:ext cx="4050792" cy="831285"/>
-              </a:xfrm>
-              <a:prstGeom prst="rect">
-                <a:avLst/>
-              </a:prstGeom>
-            </p:spPr>
-          </p:pic>
         </p:grpSp>
       </p:grpSp>
       <p:grpSp>
@@ -3482,7 +2929,7 @@
             <a:bodyPr/>
             <a:lstStyle/>
             <a:p>
-              <a:endParaRPr lang="en-US"/>
+              <a:endParaRPr lang="en-US" dirty="0"/>
             </a:p>
           </p:txBody>
         </p:sp>
@@ -3500,10 +2947,10 @@
           </p:nvGrpSpPr>
           <p:grpSpPr>
             <a:xfrm>
-              <a:off x="-5147734" y="3003582"/>
-              <a:ext cx="4033889" cy="3435096"/>
-              <a:chOff x="347472" y="4919472"/>
-              <a:chExt cx="4033889" cy="3435096"/>
+              <a:off x="-5184310" y="3003582"/>
+              <a:ext cx="4023360" cy="1316736"/>
+              <a:chOff x="310896" y="4919472"/>
+              <a:chExt cx="4023360" cy="1316736"/>
             </a:xfrm>
           </p:grpSpPr>
           <p:sp>
@@ -3579,244 +3026,6 @@
           </p:sp>
           <p:sp>
             <p:nvSpPr>
-              <p:cNvPr id="20" name="Text 18"/>
-              <p:cNvSpPr/>
-              <p:nvPr/>
-            </p:nvSpPr>
-            <p:spPr>
-              <a:xfrm>
-                <a:off x="347472" y="5285232"/>
-                <a:ext cx="3986784" cy="201168"/>
-              </a:xfrm>
-              <a:prstGeom prst="rect">
-                <a:avLst/>
-              </a:prstGeom>
-              <a:noFill/>
-              <a:ln/>
-            </p:spPr>
-            <p:txBody>
-              <a:bodyPr wrap="square" lIns="0" tIns="0" rIns="0" bIns="0" rtlCol="0" anchor="t"/>
-              <a:lstStyle/>
-              <a:p>
-                <a:pPr marL="0" indent="0" algn="l">
-                  <a:spcAft>
-                    <a:spcPts val="200"/>
-                  </a:spcAft>
-                  <a:buNone/>
-                </a:pPr>
-                <a:r>
-                  <a:rPr lang="en-US" sz="780" dirty="0">
-                    <a:solidFill>
-                      <a:srgbClr val="475569"/>
-                    </a:solidFill>
-                    <a:latin typeface="Calibri" pitchFamily="34" charset="0"/>
-                    <a:ea typeface="Calibri" pitchFamily="34" charset="-122"/>
-                    <a:cs typeface="Calibri" pitchFamily="34" charset="-120"/>
-                  </a:rPr>
-                  <a:t>Full-stack system design integrating AI into clinical workflows:</a:t>
-                </a:r>
-                <a:endParaRPr lang="en-US" sz="780" dirty="0"/>
-              </a:p>
-            </p:txBody>
-          </p:sp>
-          <p:sp>
-            <p:nvSpPr>
-              <p:cNvPr id="21" name="Shape 19"/>
-              <p:cNvSpPr/>
-              <p:nvPr/>
-            </p:nvSpPr>
-            <p:spPr>
-              <a:xfrm>
-                <a:off x="347472" y="5596128"/>
-                <a:ext cx="73152" cy="73152"/>
-              </a:xfrm>
-              <a:prstGeom prst="ellipse">
-                <a:avLst/>
-              </a:prstGeom>
-              <a:solidFill>
-                <a:srgbClr val="0D9488"/>
-              </a:solidFill>
-              <a:ln w="12700">
-                <a:solidFill>
-                  <a:srgbClr val="0D9488"/>
-                </a:solidFill>
-                <a:prstDash val="solid"/>
-              </a:ln>
-            </p:spPr>
-            <p:txBody>
-              <a:bodyPr/>
-              <a:lstStyle/>
-              <a:p>
-                <a:endParaRPr lang="en-US"/>
-              </a:p>
-            </p:txBody>
-          </p:sp>
-          <p:sp>
-            <p:nvSpPr>
-              <p:cNvPr id="22" name="Text 20"/>
-              <p:cNvSpPr/>
-              <p:nvPr/>
-            </p:nvSpPr>
-            <p:spPr>
-              <a:xfrm>
-                <a:off x="475488" y="5522976"/>
-                <a:ext cx="3858768" cy="219456"/>
-              </a:xfrm>
-              <a:prstGeom prst="rect">
-                <a:avLst/>
-              </a:prstGeom>
-              <a:noFill/>
-              <a:ln/>
-            </p:spPr>
-            <p:txBody>
-              <a:bodyPr wrap="square" lIns="0" tIns="0" rIns="0" bIns="0" rtlCol="0" anchor="ctr"/>
-              <a:lstStyle/>
-              <a:p>
-                <a:pPr marL="0" indent="0">
-                  <a:buNone/>
-                </a:pPr>
-                <a:r>
-                  <a:rPr lang="en-US" sz="750" b="1" dirty="0">
-                    <a:solidFill>
-                      <a:srgbClr val="1E293B"/>
-                    </a:solidFill>
-                    <a:latin typeface="Calibri" pitchFamily="34" charset="0"/>
-                    <a:ea typeface="Calibri" pitchFamily="34" charset="-122"/>
-                    <a:cs typeface="Calibri" pitchFamily="34" charset="-120"/>
-                  </a:rPr>
-                  <a:t>Architecture  </a:t>
-                </a:r>
-                <a:r>
-                  <a:rPr lang="en-US" sz="750" dirty="0">
-                    <a:solidFill>
-                      <a:srgbClr val="475569"/>
-                    </a:solidFill>
-                    <a:latin typeface="Calibri" pitchFamily="34" charset="0"/>
-                    <a:ea typeface="Calibri" pitchFamily="34" charset="-122"/>
-                    <a:cs typeface="Calibri" pitchFamily="34" charset="-120"/>
-                  </a:rPr>
-                  <a:t>Multi-layer (client · API · business logic · data layer)</a:t>
-                </a:r>
-                <a:endParaRPr lang="en-US" sz="750" dirty="0"/>
-              </a:p>
-            </p:txBody>
-          </p:sp>
-          <p:sp>
-            <p:nvSpPr>
-              <p:cNvPr id="23" name="Shape 21"/>
-              <p:cNvSpPr/>
-              <p:nvPr/>
-            </p:nvSpPr>
-            <p:spPr>
-              <a:xfrm>
-                <a:off x="347472" y="5815584"/>
-                <a:ext cx="73152" cy="73152"/>
-              </a:xfrm>
-              <a:prstGeom prst="ellipse">
-                <a:avLst/>
-              </a:prstGeom>
-              <a:solidFill>
-                <a:srgbClr val="0D9488"/>
-              </a:solidFill>
-              <a:ln w="12700">
-                <a:solidFill>
-                  <a:srgbClr val="0D9488"/>
-                </a:solidFill>
-                <a:prstDash val="solid"/>
-              </a:ln>
-            </p:spPr>
-            <p:txBody>
-              <a:bodyPr/>
-              <a:lstStyle/>
-              <a:p>
-                <a:endParaRPr lang="en-US"/>
-              </a:p>
-            </p:txBody>
-          </p:sp>
-          <p:sp>
-            <p:nvSpPr>
-              <p:cNvPr id="24" name="Text 22"/>
-              <p:cNvSpPr/>
-              <p:nvPr/>
-            </p:nvSpPr>
-            <p:spPr>
-              <a:xfrm>
-                <a:off x="475488" y="5769864"/>
-                <a:ext cx="3858768" cy="219456"/>
-              </a:xfrm>
-              <a:prstGeom prst="rect">
-                <a:avLst/>
-              </a:prstGeom>
-              <a:noFill/>
-              <a:ln/>
-            </p:spPr>
-            <p:txBody>
-              <a:bodyPr wrap="square" lIns="0" tIns="0" rIns="0" bIns="0" rtlCol="0" anchor="ctr"/>
-              <a:lstStyle/>
-              <a:p>
-                <a:pPr marL="0" indent="0">
-                  <a:buNone/>
-                </a:pPr>
-                <a:r>
-                  <a:rPr lang="en-US" sz="750" b="1" dirty="0">
-                    <a:solidFill>
-                      <a:srgbClr val="1E293B"/>
-                    </a:solidFill>
-                    <a:latin typeface="Calibri" pitchFamily="34" charset="0"/>
-                    <a:ea typeface="Calibri" pitchFamily="34" charset="-122"/>
-                    <a:cs typeface="Calibri" pitchFamily="34" charset="-120"/>
-                  </a:rPr>
-                  <a:t>Backend  </a:t>
-                </a:r>
-                <a:r>
-                  <a:rPr lang="en-US" sz="750" dirty="0">
-                    <a:solidFill>
-                      <a:srgbClr val="475569"/>
-                    </a:solidFill>
-                    <a:latin typeface="Calibri" pitchFamily="34" charset="0"/>
-                    <a:ea typeface="Calibri" pitchFamily="34" charset="-122"/>
-                    <a:cs typeface="Calibri" pitchFamily="34" charset="-120"/>
-                  </a:rPr>
-                  <a:t>FastAPI with RESTful endpoints</a:t>
-                </a:r>
-                <a:endParaRPr lang="en-US" sz="750" dirty="0"/>
-              </a:p>
-            </p:txBody>
-          </p:sp>
-          <p:sp>
-            <p:nvSpPr>
-              <p:cNvPr id="25" name="Shape 23"/>
-              <p:cNvSpPr/>
-              <p:nvPr/>
-            </p:nvSpPr>
-            <p:spPr>
-              <a:xfrm>
-                <a:off x="347472" y="6062472"/>
-                <a:ext cx="73152" cy="73152"/>
-              </a:xfrm>
-              <a:prstGeom prst="ellipse">
-                <a:avLst/>
-              </a:prstGeom>
-              <a:solidFill>
-                <a:srgbClr val="0D9488"/>
-              </a:solidFill>
-              <a:ln w="12700">
-                <a:solidFill>
-                  <a:srgbClr val="0D9488"/>
-                </a:solidFill>
-                <a:prstDash val="solid"/>
-              </a:ln>
-            </p:spPr>
-            <p:txBody>
-              <a:bodyPr/>
-              <a:lstStyle/>
-              <a:p>
-                <a:endParaRPr lang="en-US"/>
-              </a:p>
-            </p:txBody>
-          </p:sp>
-          <p:sp>
-            <p:nvSpPr>
               <p:cNvPr id="26" name="Text 24"/>
               <p:cNvSpPr/>
               <p:nvPr/>
@@ -3839,274 +3048,6 @@
                 <a:pPr marL="0" indent="0">
                   <a:buNone/>
                 </a:pPr>
-                <a:r>
-                  <a:rPr lang="en-US" sz="750" b="1" dirty="0">
-                    <a:solidFill>
-                      <a:srgbClr val="1E293B"/>
-                    </a:solidFill>
-                    <a:latin typeface="Calibri" pitchFamily="34" charset="0"/>
-                    <a:ea typeface="Calibri" pitchFamily="34" charset="-122"/>
-                    <a:cs typeface="Calibri" pitchFamily="34" charset="-120"/>
-                  </a:rPr>
-                  <a:t>Frontend  </a:t>
-                </a:r>
-                <a:r>
-                  <a:rPr lang="en-US" sz="750" dirty="0">
-                    <a:solidFill>
-                      <a:srgbClr val="475569"/>
-                    </a:solidFill>
-                    <a:latin typeface="Calibri" pitchFamily="34" charset="0"/>
-                    <a:ea typeface="Calibri" pitchFamily="34" charset="-122"/>
-                    <a:cs typeface="Calibri" pitchFamily="34" charset="-120"/>
-                  </a:rPr>
-                  <a:t>React (web) and React Native (mobile)</a:t>
-                </a:r>
-                <a:endParaRPr lang="en-US" sz="750" dirty="0"/>
-              </a:p>
-            </p:txBody>
-          </p:sp>
-          <p:sp>
-            <p:nvSpPr>
-              <p:cNvPr id="27" name="Shape 25"/>
-              <p:cNvSpPr/>
-              <p:nvPr/>
-            </p:nvSpPr>
-            <p:spPr>
-              <a:xfrm>
-                <a:off x="347472" y="6309360"/>
-                <a:ext cx="73152" cy="73152"/>
-              </a:xfrm>
-              <a:prstGeom prst="ellipse">
-                <a:avLst/>
-              </a:prstGeom>
-              <a:solidFill>
-                <a:srgbClr val="0D9488"/>
-              </a:solidFill>
-              <a:ln w="12700">
-                <a:solidFill>
-                  <a:srgbClr val="0D9488"/>
-                </a:solidFill>
-                <a:prstDash val="solid"/>
-              </a:ln>
-            </p:spPr>
-            <p:txBody>
-              <a:bodyPr/>
-              <a:lstStyle/>
-              <a:p>
-                <a:endParaRPr lang="en-US"/>
-              </a:p>
-            </p:txBody>
-          </p:sp>
-          <p:sp>
-            <p:nvSpPr>
-              <p:cNvPr id="28" name="Text 26"/>
-              <p:cNvSpPr/>
-              <p:nvPr/>
-            </p:nvSpPr>
-            <p:spPr>
-              <a:xfrm>
-                <a:off x="475488" y="6263640"/>
-                <a:ext cx="3858768" cy="219456"/>
-              </a:xfrm>
-              <a:prstGeom prst="rect">
-                <a:avLst/>
-              </a:prstGeom>
-              <a:noFill/>
-              <a:ln/>
-            </p:spPr>
-            <p:txBody>
-              <a:bodyPr wrap="square" lIns="0" tIns="0" rIns="0" bIns="0" rtlCol="0" anchor="ctr"/>
-              <a:lstStyle/>
-              <a:p>
-                <a:pPr marL="0" indent="0">
-                  <a:buNone/>
-                </a:pPr>
-                <a:r>
-                  <a:rPr lang="en-US" sz="750" b="1" dirty="0">
-                    <a:solidFill>
-                      <a:srgbClr val="1E293B"/>
-                    </a:solidFill>
-                    <a:latin typeface="Calibri" pitchFamily="34" charset="0"/>
-                    <a:ea typeface="Calibri" pitchFamily="34" charset="-122"/>
-                    <a:cs typeface="Calibri" pitchFamily="34" charset="-120"/>
-                  </a:rPr>
-                  <a:t>Database  </a:t>
-                </a:r>
-                <a:r>
-                  <a:rPr lang="en-US" sz="750" dirty="0">
-                    <a:solidFill>
-                      <a:srgbClr val="475569"/>
-                    </a:solidFill>
-                    <a:latin typeface="Calibri" pitchFamily="34" charset="0"/>
-                    <a:ea typeface="Calibri" pitchFamily="34" charset="-122"/>
-                    <a:cs typeface="Calibri" pitchFamily="34" charset="-120"/>
-                  </a:rPr>
-                  <a:t>MySQL with structured clinical schema</a:t>
-                </a:r>
-                <a:endParaRPr lang="en-US" sz="750" dirty="0"/>
-              </a:p>
-            </p:txBody>
-          </p:sp>
-          <p:sp>
-            <p:nvSpPr>
-              <p:cNvPr id="29" name="Shape 27"/>
-              <p:cNvSpPr/>
-              <p:nvPr/>
-            </p:nvSpPr>
-            <p:spPr>
-              <a:xfrm>
-                <a:off x="347472" y="6556248"/>
-                <a:ext cx="73152" cy="73152"/>
-              </a:xfrm>
-              <a:prstGeom prst="ellipse">
-                <a:avLst/>
-              </a:prstGeom>
-              <a:solidFill>
-                <a:srgbClr val="0D9488"/>
-              </a:solidFill>
-              <a:ln w="12700">
-                <a:solidFill>
-                  <a:srgbClr val="0D9488"/>
-                </a:solidFill>
-                <a:prstDash val="solid"/>
-              </a:ln>
-            </p:spPr>
-            <p:txBody>
-              <a:bodyPr/>
-              <a:lstStyle/>
-              <a:p>
-                <a:endParaRPr lang="en-US"/>
-              </a:p>
-            </p:txBody>
-          </p:sp>
-          <p:sp>
-            <p:nvSpPr>
-              <p:cNvPr id="30" name="Text 28"/>
-              <p:cNvSpPr/>
-              <p:nvPr/>
-            </p:nvSpPr>
-            <p:spPr>
-              <a:xfrm>
-                <a:off x="475488" y="6510528"/>
-                <a:ext cx="3858768" cy="219456"/>
-              </a:xfrm>
-              <a:prstGeom prst="rect">
-                <a:avLst/>
-              </a:prstGeom>
-              <a:noFill/>
-              <a:ln/>
-            </p:spPr>
-            <p:txBody>
-              <a:bodyPr wrap="square" lIns="0" tIns="0" rIns="0" bIns="0" rtlCol="0" anchor="ctr"/>
-              <a:lstStyle/>
-              <a:p>
-                <a:pPr marL="0" indent="0">
-                  <a:buNone/>
-                </a:pPr>
-                <a:r>
-                  <a:rPr lang="en-US" sz="750" b="1" dirty="0">
-                    <a:solidFill>
-                      <a:srgbClr val="1E293B"/>
-                    </a:solidFill>
-                    <a:latin typeface="Calibri" pitchFamily="34" charset="0"/>
-                    <a:ea typeface="Calibri" pitchFamily="34" charset="-122"/>
-                    <a:cs typeface="Calibri" pitchFamily="34" charset="-120"/>
-                  </a:rPr>
-                  <a:t>AI Engine  </a:t>
-                </a:r>
-                <a:r>
-                  <a:rPr lang="en-US" sz="750" dirty="0">
-                    <a:solidFill>
-                      <a:srgbClr val="475569"/>
-                    </a:solidFill>
-                    <a:latin typeface="Calibri" pitchFamily="34" charset="0"/>
-                    <a:ea typeface="Calibri" pitchFamily="34" charset="-122"/>
-                    <a:cs typeface="Calibri" pitchFamily="34" charset="-120"/>
-                  </a:rPr>
-                  <a:t>Local LLM — BioMistral via Ollama</a:t>
-                </a:r>
-                <a:endParaRPr lang="en-US" sz="750" dirty="0"/>
-              </a:p>
-            </p:txBody>
-          </p:sp>
-          <p:sp>
-            <p:nvSpPr>
-              <p:cNvPr id="31" name="Shape 29"/>
-              <p:cNvSpPr/>
-              <p:nvPr/>
-            </p:nvSpPr>
-            <p:spPr>
-              <a:xfrm>
-                <a:off x="347472" y="6803136"/>
-                <a:ext cx="73152" cy="73152"/>
-              </a:xfrm>
-              <a:prstGeom prst="ellipse">
-                <a:avLst/>
-              </a:prstGeom>
-              <a:solidFill>
-                <a:srgbClr val="0D9488"/>
-              </a:solidFill>
-              <a:ln w="12700">
-                <a:solidFill>
-                  <a:srgbClr val="0D9488"/>
-                </a:solidFill>
-                <a:prstDash val="solid"/>
-              </a:ln>
-            </p:spPr>
-            <p:txBody>
-              <a:bodyPr/>
-              <a:lstStyle/>
-              <a:p>
-                <a:endParaRPr lang="en-US"/>
-              </a:p>
-            </p:txBody>
-          </p:sp>
-          <p:sp>
-            <p:nvSpPr>
-              <p:cNvPr id="32" name="Text 30"/>
-              <p:cNvSpPr/>
-              <p:nvPr/>
-            </p:nvSpPr>
-            <p:spPr>
-              <a:xfrm>
-                <a:off x="475488" y="6757416"/>
-                <a:ext cx="3858768" cy="219456"/>
-              </a:xfrm>
-              <a:prstGeom prst="rect">
-                <a:avLst/>
-              </a:prstGeom>
-              <a:noFill/>
-              <a:ln/>
-            </p:spPr>
-            <p:txBody>
-              <a:bodyPr wrap="square" lIns="0" tIns="0" rIns="0" bIns="0" rtlCol="0" anchor="ctr"/>
-              <a:lstStyle/>
-              <a:p>
-                <a:pPr marL="0" indent="0">
-                  <a:buNone/>
-                </a:pPr>
-                <a:r>
-                  <a:rPr lang="en-US" sz="750" b="1" dirty="0">
-                    <a:solidFill>
-                      <a:srgbClr val="1E293B"/>
-                    </a:solidFill>
-                    <a:latin typeface="Calibri" pitchFamily="34" charset="0"/>
-                    <a:ea typeface="Calibri" pitchFamily="34" charset="-122"/>
-                    <a:cs typeface="Calibri" pitchFamily="34" charset="-120"/>
-                  </a:rPr>
-                  <a:t>Security  </a:t>
-                </a:r>
-                <a:r>
-                  <a:rPr lang="en-US" sz="750" dirty="0">
-                    <a:solidFill>
-                      <a:srgbClr val="475569"/>
-                    </a:solidFill>
-                    <a:latin typeface="Calibri" pitchFamily="34" charset="0"/>
-                    <a:ea typeface="Calibri" pitchFamily="34" charset="-122"/>
-                    <a:cs typeface="Calibri" pitchFamily="34" charset="-120"/>
-                  </a:rPr>
-                  <a:t>JWT auth · role-based access control · audit logging</a:t>
-                </a:r>
                 <a:endParaRPr lang="en-US" sz="750" dirty="0"/>
               </a:p>
             </p:txBody>
@@ -4119,7 +3060,7 @@
             </p:nvSpPr>
             <p:spPr>
               <a:xfrm>
-                <a:off x="347472" y="7050024"/>
+                <a:off x="310896" y="5345777"/>
                 <a:ext cx="3986784" cy="457200"/>
               </a:xfrm>
               <a:prstGeom prst="rect">
@@ -4132,95 +3073,113 @@
               <a:bodyPr wrap="square" lIns="0" tIns="0" rIns="0" bIns="0" rtlCol="0" anchor="t"/>
               <a:lstStyle/>
               <a:p>
-                <a:pPr marL="0" indent="0" algn="l">
-                  <a:spcAft>
-                    <a:spcPts val="200"/>
-                  </a:spcAft>
-                  <a:buNone/>
-                </a:pPr>
                 <a:r>
-                  <a:rPr lang="en-US" sz="750" dirty="0">
-                    <a:solidFill>
-                      <a:srgbClr val="475569"/>
-                    </a:solidFill>
-                    <a:latin typeface="Calibri" pitchFamily="34" charset="0"/>
-                    <a:ea typeface="Calibri" pitchFamily="34" charset="-122"/>
-                    <a:cs typeface="Calibri" pitchFamily="34" charset="-120"/>
+                  <a:rPr lang="en-US" sz="780" dirty="0">
+                    <a:latin typeface="+mj-lt"/>
                   </a:rPr>
-                  <a:t>On-premise deployment (GDPR/CNDP) · Synchronous LLM inference for real-time usability · Structured clinical data model for interoperability. System was iteratively developed and validated in a real clinical environment.</a:t>
+                  <a:t>The system follows a layered architecture connecting client applications to a centralized backend, which orchestrates service-level processing and AI-driven analysis ³. User inputs are transmitted from client interfaces to the backend, where they are structured and routed through dedicated services for processing. These services interact with a combined data and AI layer, integrating database storage with a local inference engine to generate diagnostic insights and recommendations. The design ensures efficient data flow, secure handling, and seamless integration between application logic and AI-supported decision-making.</a:t>
                 </a:r>
-                <a:endParaRPr lang="en-US" sz="750" dirty="0"/>
               </a:p>
             </p:txBody>
           </p:sp>
-          <p:pic>
-            <p:nvPicPr>
-              <p:cNvPr id="78" name="Image 77">
-                <a:extLst>
-                  <a:ext uri="{FF2B5EF4-FFF2-40B4-BE49-F238E27FC236}">
-                    <a16:creationId xmlns:a16="http://schemas.microsoft.com/office/drawing/2014/main" id="{16008BEF-42F7-8A1C-6D3D-0CE34A849B64}"/>
-                  </a:ext>
-                </a:extLst>
-              </p:cNvPr>
-              <p:cNvPicPr>
-                <a:picLocks noChangeAspect="1"/>
-              </p:cNvPicPr>
-              <p:nvPr/>
-            </p:nvPicPr>
-            <p:blipFill>
-              <a:blip r:embed="rId4"/>
-              <a:stretch>
-                <a:fillRect/>
-              </a:stretch>
-            </p:blipFill>
-            <p:spPr>
-              <a:xfrm>
-                <a:off x="355231" y="7401940"/>
-                <a:ext cx="4026130" cy="952628"/>
-              </a:xfrm>
-              <a:prstGeom prst="rect">
-                <a:avLst/>
-              </a:prstGeom>
-            </p:spPr>
-          </p:pic>
-          <p:pic>
-            <p:nvPicPr>
-              <p:cNvPr id="91" name="Image 90">
-                <a:extLst>
-                  <a:ext uri="{FF2B5EF4-FFF2-40B4-BE49-F238E27FC236}">
-                    <a16:creationId xmlns:a16="http://schemas.microsoft.com/office/drawing/2014/main" id="{81EEA279-71E4-609D-3C1F-2AD58BAB33F6}"/>
-                  </a:ext>
-                </a:extLst>
-              </p:cNvPr>
-              <p:cNvPicPr>
-                <a:picLocks noChangeAspect="1"/>
-              </p:cNvPicPr>
-              <p:nvPr/>
-            </p:nvPicPr>
-            <p:blipFill>
-              <a:blip r:embed="rId5"/>
-              <a:stretch>
-                <a:fillRect/>
-              </a:stretch>
-            </p:blipFill>
-            <p:spPr>
-              <a:xfrm>
-                <a:off x="1050014" y="7751285"/>
-                <a:ext cx="381117" cy="176563"/>
-              </a:xfrm>
-              <a:prstGeom prst="rect">
-                <a:avLst/>
-              </a:prstGeom>
-            </p:spPr>
-          </p:pic>
         </p:grpSp>
       </p:grpSp>
       <p:pic>
         <p:nvPicPr>
-          <p:cNvPr id="53" name="Image 52">
+          <p:cNvPr id="86" name="Image 85">
             <a:extLst>
               <a:ext uri="{FF2B5EF4-FFF2-40B4-BE49-F238E27FC236}">
-                <a16:creationId xmlns:a16="http://schemas.microsoft.com/office/drawing/2014/main" id="{665A90B1-7248-9ADF-F3D2-D69773E22B50}"/>
+                <a16:creationId xmlns:a16="http://schemas.microsoft.com/office/drawing/2014/main" id="{E51FCE80-40AE-F451-5291-1B4ED0A18012}"/>
+              </a:ext>
+            </a:extLst>
+          </p:cNvPr>
+          <p:cNvPicPr>
+            <a:picLocks noChangeAspect="1"/>
+          </p:cNvPicPr>
+          <p:nvPr/>
+        </p:nvPicPr>
+        <p:blipFill>
+          <a:blip r:embed="rId3"/>
+          <a:stretch>
+            <a:fillRect/>
+          </a:stretch>
+        </p:blipFill>
+        <p:spPr>
+          <a:xfrm>
+            <a:off x="7562453" y="103108"/>
+            <a:ext cx="1457633" cy="640671"/>
+          </a:xfrm>
+          <a:prstGeom prst="rect">
+            <a:avLst/>
+          </a:prstGeom>
+        </p:spPr>
+      </p:pic>
+      <p:pic>
+        <p:nvPicPr>
+          <p:cNvPr id="92" name="Image 91">
+            <a:extLst>
+              <a:ext uri="{FF2B5EF4-FFF2-40B4-BE49-F238E27FC236}">
+                <a16:creationId xmlns:a16="http://schemas.microsoft.com/office/drawing/2014/main" id="{9AA40429-F033-8D28-1293-4F158F838133}"/>
+              </a:ext>
+            </a:extLst>
+          </p:cNvPr>
+          <p:cNvPicPr>
+            <a:picLocks noChangeAspect="1"/>
+          </p:cNvPicPr>
+          <p:nvPr/>
+        </p:nvPicPr>
+        <p:blipFill>
+          <a:blip r:embed="rId4"/>
+          <a:stretch>
+            <a:fillRect/>
+          </a:stretch>
+        </p:blipFill>
+        <p:spPr>
+          <a:xfrm>
+            <a:off x="0" y="157625"/>
+            <a:ext cx="942901" cy="432163"/>
+          </a:xfrm>
+          <a:prstGeom prst="rect">
+            <a:avLst/>
+          </a:prstGeom>
+        </p:spPr>
+      </p:pic>
+      <p:pic>
+        <p:nvPicPr>
+          <p:cNvPr id="94" name="Image 93">
+            <a:extLst>
+              <a:ext uri="{FF2B5EF4-FFF2-40B4-BE49-F238E27FC236}">
+                <a16:creationId xmlns:a16="http://schemas.microsoft.com/office/drawing/2014/main" id="{19734838-724F-41EA-BE9F-D74AC98C5ACB}"/>
+              </a:ext>
+            </a:extLst>
+          </p:cNvPr>
+          <p:cNvPicPr>
+            <a:picLocks noChangeAspect="1"/>
+          </p:cNvPicPr>
+          <p:nvPr/>
+        </p:nvPicPr>
+        <p:blipFill>
+          <a:blip r:embed="rId5"/>
+          <a:stretch>
+            <a:fillRect/>
+          </a:stretch>
+        </p:blipFill>
+        <p:spPr>
+          <a:xfrm>
+            <a:off x="6588252" y="78204"/>
+            <a:ext cx="790507" cy="636551"/>
+          </a:xfrm>
+          <a:prstGeom prst="rect">
+            <a:avLst/>
+          </a:prstGeom>
+        </p:spPr>
+      </p:pic>
+      <p:pic>
+        <p:nvPicPr>
+          <p:cNvPr id="96" name="Image 95">
+            <a:extLst>
+              <a:ext uri="{FF2B5EF4-FFF2-40B4-BE49-F238E27FC236}">
+                <a16:creationId xmlns:a16="http://schemas.microsoft.com/office/drawing/2014/main" id="{6DA39B9C-C794-DF7C-AD07-CA8D9EE0682A}"/>
               </a:ext>
             </a:extLst>
           </p:cNvPr>
@@ -4237,8 +3196,8 @@
         </p:blipFill>
         <p:spPr>
           <a:xfrm>
-            <a:off x="6568593" y="25462"/>
-            <a:ext cx="786167" cy="744158"/>
+            <a:off x="1044595" y="210612"/>
+            <a:ext cx="942901" cy="382257"/>
           </a:xfrm>
           <a:prstGeom prst="rect">
             <a:avLst/>
@@ -4247,10 +3206,10 @@
       </p:pic>
       <p:pic>
         <p:nvPicPr>
-          <p:cNvPr id="57" name="Image 56">
+          <p:cNvPr id="55" name="Image 54">
             <a:extLst>
               <a:ext uri="{FF2B5EF4-FFF2-40B4-BE49-F238E27FC236}">
-                <a16:creationId xmlns:a16="http://schemas.microsoft.com/office/drawing/2014/main" id="{A45EF8EF-28E1-4515-EBC9-111A2A73B202}"/>
+                <a16:creationId xmlns:a16="http://schemas.microsoft.com/office/drawing/2014/main" id="{745688C1-8703-A9C8-581D-B87A2AE4AC97}"/>
               </a:ext>
             </a:extLst>
           </p:cNvPr>
@@ -4267,8 +3226,8 @@
         </p:blipFill>
         <p:spPr>
           <a:xfrm>
-            <a:off x="-46736" y="-81521"/>
-            <a:ext cx="1651508" cy="844221"/>
+            <a:off x="2196868" y="129357"/>
+            <a:ext cx="549006" cy="549006"/>
           </a:xfrm>
           <a:prstGeom prst="rect">
             <a:avLst/>
@@ -4277,10 +3236,10 @@
       </p:pic>
       <p:pic>
         <p:nvPicPr>
-          <p:cNvPr id="70" name="Image 69">
+          <p:cNvPr id="93" name="Image 92">
             <a:extLst>
               <a:ext uri="{FF2B5EF4-FFF2-40B4-BE49-F238E27FC236}">
-                <a16:creationId xmlns:a16="http://schemas.microsoft.com/office/drawing/2014/main" id="{112B5394-5054-979D-713C-A04EF93A748C}"/>
+                <a16:creationId xmlns:a16="http://schemas.microsoft.com/office/drawing/2014/main" id="{2AE0566B-7F18-1DE6-D5E7-C618202E8B5F}"/>
               </a:ext>
             </a:extLst>
           </p:cNvPr>
@@ -4297,8 +3256,8 @@
         </p:blipFill>
         <p:spPr>
           <a:xfrm>
-            <a:off x="7531004" y="9549"/>
-            <a:ext cx="1494124" cy="735497"/>
+            <a:off x="6998120" y="3696091"/>
+            <a:ext cx="1959686" cy="822833"/>
           </a:xfrm>
           <a:prstGeom prst="rect">
             <a:avLst/>
@@ -4307,10 +3266,10 @@
       </p:pic>
       <p:pic>
         <p:nvPicPr>
-          <p:cNvPr id="55" name="Image 54">
+          <p:cNvPr id="97" name="Image 96">
             <a:extLst>
               <a:ext uri="{FF2B5EF4-FFF2-40B4-BE49-F238E27FC236}">
-                <a16:creationId xmlns:a16="http://schemas.microsoft.com/office/drawing/2014/main" id="{8D0B0727-17A0-6B8D-88FA-AAD8C200831B}"/>
+                <a16:creationId xmlns:a16="http://schemas.microsoft.com/office/drawing/2014/main" id="{0BF07603-99E6-E171-81B1-8557AA930D13}"/>
               </a:ext>
             </a:extLst>
           </p:cNvPr>
@@ -4327,8 +3286,68 @@
         </p:blipFill>
         <p:spPr>
           <a:xfrm>
-            <a:off x="1483441" y="162647"/>
-            <a:ext cx="1560256" cy="422569"/>
+            <a:off x="4942816" y="3696091"/>
+            <a:ext cx="1929747" cy="798314"/>
+          </a:xfrm>
+          <a:prstGeom prst="rect">
+            <a:avLst/>
+          </a:prstGeom>
+        </p:spPr>
+      </p:pic>
+      <p:pic>
+        <p:nvPicPr>
+          <p:cNvPr id="103" name="Image 102">
+            <a:extLst>
+              <a:ext uri="{FF2B5EF4-FFF2-40B4-BE49-F238E27FC236}">
+                <a16:creationId xmlns:a16="http://schemas.microsoft.com/office/drawing/2014/main" id="{BD9F658C-3C49-EBBB-6904-2632D0D1D84E}"/>
+              </a:ext>
+            </a:extLst>
+          </p:cNvPr>
+          <p:cNvPicPr>
+            <a:picLocks noChangeAspect="1"/>
+          </p:cNvPicPr>
+          <p:nvPr/>
+        </p:nvPicPr>
+        <p:blipFill>
+          <a:blip r:embed="rId10"/>
+          <a:stretch>
+            <a:fillRect/>
+          </a:stretch>
+        </p:blipFill>
+        <p:spPr>
+          <a:xfrm>
+            <a:off x="342053" y="9234935"/>
+            <a:ext cx="3950208" cy="2134485"/>
+          </a:xfrm>
+          <a:prstGeom prst="rect">
+            <a:avLst/>
+          </a:prstGeom>
+        </p:spPr>
+      </p:pic>
+      <p:pic>
+        <p:nvPicPr>
+          <p:cNvPr id="105" name="Image 104">
+            <a:extLst>
+              <a:ext uri="{FF2B5EF4-FFF2-40B4-BE49-F238E27FC236}">
+                <a16:creationId xmlns:a16="http://schemas.microsoft.com/office/drawing/2014/main" id="{99B81D25-51C4-6053-DBA4-5827B3A4A01B}"/>
+              </a:ext>
+            </a:extLst>
+          </p:cNvPr>
+          <p:cNvPicPr>
+            <a:picLocks noChangeAspect="1"/>
+          </p:cNvPicPr>
+          <p:nvPr/>
+        </p:nvPicPr>
+        <p:blipFill>
+          <a:blip r:embed="rId11"/>
+          <a:stretch>
+            <a:fillRect/>
+          </a:stretch>
+        </p:blipFill>
+        <p:spPr>
+          <a:xfrm>
+            <a:off x="4689478" y="6310685"/>
+            <a:ext cx="4445077" cy="2422797"/>
           </a:xfrm>
           <a:prstGeom prst="rect">
             <a:avLst/>

</xml_diff>